<commit_message>
docs: update presentation and use case documents
</commit_message>
<xml_diff>
--- a/public/docs/Presentation.pptx
+++ b/public/docs/Presentation.pptx
@@ -1,26 +1,26 @@
 
 <file path=ppt/presentation.xml><?xml version="1.0" encoding="utf-8"?>
-<p:presentation xmlns:a="http://schemas.openxmlformats.org/drawingml/2006/main" xmlns:r="http://schemas.openxmlformats.org/officeDocument/2006/relationships" xmlns:p="http://schemas.openxmlformats.org/presentationml/2006/main" saveSubsetFonts="1" embedTrueTypeFonts="true">
+<p:presentation xmlns:a="http://schemas.openxmlformats.org/drawingml/2006/main" xmlns:r="http://schemas.openxmlformats.org/officeDocument/2006/relationships" xmlns:p="http://schemas.openxmlformats.org/presentationml/2006/main" embedTrueTypeFonts="1" saveSubsetFonts="1">
   <p:sldMasterIdLst>
     <p:sldMasterId id="2147483648" r:id="rId1"/>
   </p:sldMasterIdLst>
   <p:sldIdLst>
-    <p:sldId id="256" r:id="rId6"/>
-    <p:sldId id="257" r:id="rId7"/>
-    <p:sldId id="258" r:id="rId8"/>
-    <p:sldId id="259" r:id="rId9"/>
-    <p:sldId id="260" r:id="rId10"/>
-    <p:sldId id="261" r:id="rId11"/>
+    <p:sldId id="256" r:id="rId3"/>
+    <p:sldId id="257" r:id="rId4"/>
+    <p:sldId id="258" r:id="rId5"/>
+    <p:sldId id="259" r:id="rId6"/>
+    <p:sldId id="260" r:id="rId7"/>
+    <p:sldId id="261" r:id="rId8"/>
   </p:sldIdLst>
   <p:sldSz cx="18288000" cy="10287000"/>
   <p:notesSz cx="6858000" cy="9144000"/>
   <p:embeddedFontLst>
     <p:embeddedFont>
-      <p:font typeface="Canva Sans Bold" charset="1" panose="020B0803030501040103"/>
+      <p:font typeface="Canva Sans Bold" panose="020B0803030501040103"/>
       <p:regular r:id="rId12"/>
     </p:embeddedFont>
     <p:embeddedFont>
-      <p:font typeface="Canva Sans" charset="1" panose="020B0503030501040103"/>
+      <p:font typeface="Canva Sans" panose="020B0503030501040103"/>
       <p:regular r:id="rId13"/>
     </p:embeddedFont>
   </p:embeddedFontLst>
@@ -303,8 +303,6 @@
           <a:p>
             <a:fld id="{1D8BD707-D9CF-40AE-B4C6-C98DA3205C09}" type="datetimeFigureOut">
               <a:rPr lang="en-US" smtClean="0"/>
-              <a:pPr/>
-              <a:t>8/1/2011</a:t>
             </a:fld>
             <a:endParaRPr lang="en-US"/>
           </a:p>
@@ -346,8 +344,6 @@
           <a:p>
             <a:fld id="{B6F15528-21DE-4FAA-801E-634DDDAF4B2B}" type="slidenum">
               <a:rPr lang="en-US" smtClean="0"/>
-              <a:pPr/>
-              <a:t>‹#›</a:t>
             </a:fld>
             <a:endParaRPr lang="en-US"/>
           </a:p>
@@ -421,6 +417,7 @@
               <a:rPr lang="en-US" smtClean="0"/>
               <a:t>Click to edit Master text styles</a:t>
             </a:r>
+            <a:endParaRPr lang="en-US" smtClean="0"/>
           </a:p>
           <a:p>
             <a:pPr lvl="1"/>
@@ -428,6 +425,7 @@
               <a:rPr lang="en-US" smtClean="0"/>
               <a:t>Second level</a:t>
             </a:r>
+            <a:endParaRPr lang="en-US" smtClean="0"/>
           </a:p>
           <a:p>
             <a:pPr lvl="2"/>
@@ -435,6 +433,7 @@
               <a:rPr lang="en-US" smtClean="0"/>
               <a:t>Third level</a:t>
             </a:r>
+            <a:endParaRPr lang="en-US" smtClean="0"/>
           </a:p>
           <a:p>
             <a:pPr lvl="3"/>
@@ -442,6 +441,7 @@
               <a:rPr lang="en-US" smtClean="0"/>
               <a:t>Fourth level</a:t>
             </a:r>
+            <a:endParaRPr lang="en-US" smtClean="0"/>
           </a:p>
           <a:p>
             <a:pPr lvl="4"/>
@@ -470,8 +470,6 @@
           <a:p>
             <a:fld id="{1D8BD707-D9CF-40AE-B4C6-C98DA3205C09}" type="datetimeFigureOut">
               <a:rPr lang="en-US" smtClean="0"/>
-              <a:pPr/>
-              <a:t>8/1/2011</a:t>
             </a:fld>
             <a:endParaRPr lang="en-US"/>
           </a:p>
@@ -513,8 +511,6 @@
           <a:p>
             <a:fld id="{B6F15528-21DE-4FAA-801E-634DDDAF4B2B}" type="slidenum">
               <a:rPr lang="en-US" smtClean="0"/>
-              <a:pPr/>
-              <a:t>‹#›</a:t>
             </a:fld>
             <a:endParaRPr lang="en-US"/>
           </a:p>
@@ -598,6 +594,7 @@
               <a:rPr lang="en-US" smtClean="0"/>
               <a:t>Click to edit Master text styles</a:t>
             </a:r>
+            <a:endParaRPr lang="en-US" smtClean="0"/>
           </a:p>
           <a:p>
             <a:pPr lvl="1"/>
@@ -605,6 +602,7 @@
               <a:rPr lang="en-US" smtClean="0"/>
               <a:t>Second level</a:t>
             </a:r>
+            <a:endParaRPr lang="en-US" smtClean="0"/>
           </a:p>
           <a:p>
             <a:pPr lvl="2"/>
@@ -612,6 +610,7 @@
               <a:rPr lang="en-US" smtClean="0"/>
               <a:t>Third level</a:t>
             </a:r>
+            <a:endParaRPr lang="en-US" smtClean="0"/>
           </a:p>
           <a:p>
             <a:pPr lvl="3"/>
@@ -619,6 +618,7 @@
               <a:rPr lang="en-US" smtClean="0"/>
               <a:t>Fourth level</a:t>
             </a:r>
+            <a:endParaRPr lang="en-US" smtClean="0"/>
           </a:p>
           <a:p>
             <a:pPr lvl="4"/>
@@ -647,8 +647,6 @@
           <a:p>
             <a:fld id="{1D8BD707-D9CF-40AE-B4C6-C98DA3205C09}" type="datetimeFigureOut">
               <a:rPr lang="en-US" smtClean="0"/>
-              <a:pPr/>
-              <a:t>8/1/2011</a:t>
             </a:fld>
             <a:endParaRPr lang="en-US"/>
           </a:p>
@@ -690,8 +688,6 @@
           <a:p>
             <a:fld id="{B6F15528-21DE-4FAA-801E-634DDDAF4B2B}" type="slidenum">
               <a:rPr lang="en-US" smtClean="0"/>
-              <a:pPr/>
-              <a:t>‹#›</a:t>
             </a:fld>
             <a:endParaRPr lang="en-US"/>
           </a:p>
@@ -765,6 +761,7 @@
               <a:rPr lang="en-US" smtClean="0"/>
               <a:t>Click to edit Master text styles</a:t>
             </a:r>
+            <a:endParaRPr lang="en-US" smtClean="0"/>
           </a:p>
           <a:p>
             <a:pPr lvl="1"/>
@@ -772,6 +769,7 @@
               <a:rPr lang="en-US" smtClean="0"/>
               <a:t>Second level</a:t>
             </a:r>
+            <a:endParaRPr lang="en-US" smtClean="0"/>
           </a:p>
           <a:p>
             <a:pPr lvl="2"/>
@@ -779,6 +777,7 @@
               <a:rPr lang="en-US" smtClean="0"/>
               <a:t>Third level</a:t>
             </a:r>
+            <a:endParaRPr lang="en-US" smtClean="0"/>
           </a:p>
           <a:p>
             <a:pPr lvl="3"/>
@@ -786,6 +785,7 @@
               <a:rPr lang="en-US" smtClean="0"/>
               <a:t>Fourth level</a:t>
             </a:r>
+            <a:endParaRPr lang="en-US" smtClean="0"/>
           </a:p>
           <a:p>
             <a:pPr lvl="4"/>
@@ -814,8 +814,6 @@
           <a:p>
             <a:fld id="{1D8BD707-D9CF-40AE-B4C6-C98DA3205C09}" type="datetimeFigureOut">
               <a:rPr lang="en-US" smtClean="0"/>
-              <a:pPr/>
-              <a:t>8/1/2011</a:t>
             </a:fld>
             <a:endParaRPr lang="en-US"/>
           </a:p>
@@ -857,8 +855,6 @@
           <a:p>
             <a:fld id="{B6F15528-21DE-4FAA-801E-634DDDAF4B2B}" type="slidenum">
               <a:rPr lang="en-US" smtClean="0"/>
-              <a:pPr/>
-              <a:t>‹#›</a:t>
             </a:fld>
             <a:endParaRPr lang="en-US"/>
           </a:p>
@@ -1037,6 +1033,7 @@
               <a:rPr lang="en-US" smtClean="0"/>
               <a:t>Click to edit Master text styles</a:t>
             </a:r>
+            <a:endParaRPr lang="en-US" smtClean="0"/>
           </a:p>
         </p:txBody>
       </p:sp>
@@ -1057,8 +1054,6 @@
           <a:p>
             <a:fld id="{1D8BD707-D9CF-40AE-B4C6-C98DA3205C09}" type="datetimeFigureOut">
               <a:rPr lang="en-US" smtClean="0"/>
-              <a:pPr/>
-              <a:t>8/1/2011</a:t>
             </a:fld>
             <a:endParaRPr lang="en-US"/>
           </a:p>
@@ -1100,8 +1095,6 @@
           <a:p>
             <a:fld id="{B6F15528-21DE-4FAA-801E-634DDDAF4B2B}" type="slidenum">
               <a:rPr lang="en-US" smtClean="0"/>
-              <a:pPr/>
-              <a:t>‹#›</a:t>
             </a:fld>
             <a:endParaRPr lang="en-US"/>
           </a:p>
@@ -1208,6 +1201,7 @@
               <a:rPr lang="en-US" smtClean="0"/>
               <a:t>Click to edit Master text styles</a:t>
             </a:r>
+            <a:endParaRPr lang="en-US" smtClean="0"/>
           </a:p>
           <a:p>
             <a:pPr lvl="1"/>
@@ -1215,6 +1209,7 @@
               <a:rPr lang="en-US" smtClean="0"/>
               <a:t>Second level</a:t>
             </a:r>
+            <a:endParaRPr lang="en-US" smtClean="0"/>
           </a:p>
           <a:p>
             <a:pPr lvl="2"/>
@@ -1222,6 +1217,7 @@
               <a:rPr lang="en-US" smtClean="0"/>
               <a:t>Third level</a:t>
             </a:r>
+            <a:endParaRPr lang="en-US" smtClean="0"/>
           </a:p>
           <a:p>
             <a:pPr lvl="3"/>
@@ -1229,6 +1225,7 @@
               <a:rPr lang="en-US" smtClean="0"/>
               <a:t>Fourth level</a:t>
             </a:r>
+            <a:endParaRPr lang="en-US" smtClean="0"/>
           </a:p>
           <a:p>
             <a:pPr lvl="4"/>
@@ -1293,6 +1290,7 @@
               <a:rPr lang="en-US" smtClean="0"/>
               <a:t>Click to edit Master text styles</a:t>
             </a:r>
+            <a:endParaRPr lang="en-US" smtClean="0"/>
           </a:p>
           <a:p>
             <a:pPr lvl="1"/>
@@ -1300,6 +1298,7 @@
               <a:rPr lang="en-US" smtClean="0"/>
               <a:t>Second level</a:t>
             </a:r>
+            <a:endParaRPr lang="en-US" smtClean="0"/>
           </a:p>
           <a:p>
             <a:pPr lvl="2"/>
@@ -1307,6 +1306,7 @@
               <a:rPr lang="en-US" smtClean="0"/>
               <a:t>Third level</a:t>
             </a:r>
+            <a:endParaRPr lang="en-US" smtClean="0"/>
           </a:p>
           <a:p>
             <a:pPr lvl="3"/>
@@ -1314,6 +1314,7 @@
               <a:rPr lang="en-US" smtClean="0"/>
               <a:t>Fourth level</a:t>
             </a:r>
+            <a:endParaRPr lang="en-US" smtClean="0"/>
           </a:p>
           <a:p>
             <a:pPr lvl="4"/>
@@ -1342,8 +1343,6 @@
           <a:p>
             <a:fld id="{1D8BD707-D9CF-40AE-B4C6-C98DA3205C09}" type="datetimeFigureOut">
               <a:rPr lang="en-US" smtClean="0"/>
-              <a:pPr/>
-              <a:t>8/1/2011</a:t>
             </a:fld>
             <a:endParaRPr lang="en-US"/>
           </a:p>
@@ -1385,8 +1384,6 @@
           <a:p>
             <a:fld id="{B6F15528-21DE-4FAA-801E-634DDDAF4B2B}" type="slidenum">
               <a:rPr lang="en-US" smtClean="0"/>
-              <a:pPr/>
-              <a:t>‹#›</a:t>
             </a:fld>
             <a:endParaRPr lang="en-US"/>
           </a:p>
@@ -1506,6 +1503,7 @@
               <a:rPr lang="en-US" smtClean="0"/>
               <a:t>Click to edit Master text styles</a:t>
             </a:r>
+            <a:endParaRPr lang="en-US" smtClean="0"/>
           </a:p>
         </p:txBody>
       </p:sp>
@@ -1562,6 +1560,7 @@
               <a:rPr lang="en-US" smtClean="0"/>
               <a:t>Click to edit Master text styles</a:t>
             </a:r>
+            <a:endParaRPr lang="en-US" smtClean="0"/>
           </a:p>
           <a:p>
             <a:pPr lvl="1"/>
@@ -1569,6 +1568,7 @@
               <a:rPr lang="en-US" smtClean="0"/>
               <a:t>Second level</a:t>
             </a:r>
+            <a:endParaRPr lang="en-US" smtClean="0"/>
           </a:p>
           <a:p>
             <a:pPr lvl="2"/>
@@ -1576,6 +1576,7 @@
               <a:rPr lang="en-US" smtClean="0"/>
               <a:t>Third level</a:t>
             </a:r>
+            <a:endParaRPr lang="en-US" smtClean="0"/>
           </a:p>
           <a:p>
             <a:pPr lvl="3"/>
@@ -1583,6 +1584,7 @@
               <a:rPr lang="en-US" smtClean="0"/>
               <a:t>Fourth level</a:t>
             </a:r>
+            <a:endParaRPr lang="en-US" smtClean="0"/>
           </a:p>
           <a:p>
             <a:pPr lvl="4"/>
@@ -1656,6 +1658,7 @@
               <a:rPr lang="en-US" smtClean="0"/>
               <a:t>Click to edit Master text styles</a:t>
             </a:r>
+            <a:endParaRPr lang="en-US" smtClean="0"/>
           </a:p>
         </p:txBody>
       </p:sp>
@@ -1712,6 +1715,7 @@
               <a:rPr lang="en-US" smtClean="0"/>
               <a:t>Click to edit Master text styles</a:t>
             </a:r>
+            <a:endParaRPr lang="en-US" smtClean="0"/>
           </a:p>
           <a:p>
             <a:pPr lvl="1"/>
@@ -1719,6 +1723,7 @@
               <a:rPr lang="en-US" smtClean="0"/>
               <a:t>Second level</a:t>
             </a:r>
+            <a:endParaRPr lang="en-US" smtClean="0"/>
           </a:p>
           <a:p>
             <a:pPr lvl="2"/>
@@ -1726,6 +1731,7 @@
               <a:rPr lang="en-US" smtClean="0"/>
               <a:t>Third level</a:t>
             </a:r>
+            <a:endParaRPr lang="en-US" smtClean="0"/>
           </a:p>
           <a:p>
             <a:pPr lvl="3"/>
@@ -1733,6 +1739,7 @@
               <a:rPr lang="en-US" smtClean="0"/>
               <a:t>Fourth level</a:t>
             </a:r>
+            <a:endParaRPr lang="en-US" smtClean="0"/>
           </a:p>
           <a:p>
             <a:pPr lvl="4"/>
@@ -1761,8 +1768,6 @@
           <a:p>
             <a:fld id="{1D8BD707-D9CF-40AE-B4C6-C98DA3205C09}" type="datetimeFigureOut">
               <a:rPr lang="en-US" smtClean="0"/>
-              <a:pPr/>
-              <a:t>8/1/2011</a:t>
             </a:fld>
             <a:endParaRPr lang="en-US"/>
           </a:p>
@@ -1804,8 +1809,6 @@
           <a:p>
             <a:fld id="{B6F15528-21DE-4FAA-801E-634DDDAF4B2B}" type="slidenum">
               <a:rPr lang="en-US" smtClean="0"/>
-              <a:pPr/>
-              <a:t>‹#›</a:t>
             </a:fld>
             <a:endParaRPr lang="en-US"/>
           </a:p>
@@ -1876,8 +1879,6 @@
           <a:p>
             <a:fld id="{1D8BD707-D9CF-40AE-B4C6-C98DA3205C09}" type="datetimeFigureOut">
               <a:rPr lang="en-US" smtClean="0"/>
-              <a:pPr/>
-              <a:t>8/1/2011</a:t>
             </a:fld>
             <a:endParaRPr lang="en-US"/>
           </a:p>
@@ -1919,8 +1920,6 @@
           <a:p>
             <a:fld id="{B6F15528-21DE-4FAA-801E-634DDDAF4B2B}" type="slidenum">
               <a:rPr lang="en-US" smtClean="0"/>
-              <a:pPr/>
-              <a:t>‹#›</a:t>
             </a:fld>
             <a:endParaRPr lang="en-US"/>
           </a:p>
@@ -1968,8 +1967,6 @@
           <a:p>
             <a:fld id="{1D8BD707-D9CF-40AE-B4C6-C98DA3205C09}" type="datetimeFigureOut">
               <a:rPr lang="en-US" smtClean="0"/>
-              <a:pPr/>
-              <a:t>8/1/2011</a:t>
             </a:fld>
             <a:endParaRPr lang="en-US"/>
           </a:p>
@@ -2011,8 +2008,6 @@
           <a:p>
             <a:fld id="{B6F15528-21DE-4FAA-801E-634DDDAF4B2B}" type="slidenum">
               <a:rPr lang="en-US" smtClean="0"/>
-              <a:pPr/>
-              <a:t>‹#›</a:t>
             </a:fld>
             <a:endParaRPr lang="en-US"/>
           </a:p>
@@ -2128,6 +2123,7 @@
               <a:rPr lang="en-US" smtClean="0"/>
               <a:t>Click to edit Master text styles</a:t>
             </a:r>
+            <a:endParaRPr lang="en-US" smtClean="0"/>
           </a:p>
           <a:p>
             <a:pPr lvl="1"/>
@@ -2135,6 +2131,7 @@
               <a:rPr lang="en-US" smtClean="0"/>
               <a:t>Second level</a:t>
             </a:r>
+            <a:endParaRPr lang="en-US" smtClean="0"/>
           </a:p>
           <a:p>
             <a:pPr lvl="2"/>
@@ -2142,6 +2139,7 @@
               <a:rPr lang="en-US" smtClean="0"/>
               <a:t>Third level</a:t>
             </a:r>
+            <a:endParaRPr lang="en-US" smtClean="0"/>
           </a:p>
           <a:p>
             <a:pPr lvl="3"/>
@@ -2149,6 +2147,7 @@
               <a:rPr lang="en-US" smtClean="0"/>
               <a:t>Fourth level</a:t>
             </a:r>
+            <a:endParaRPr lang="en-US" smtClean="0"/>
           </a:p>
           <a:p>
             <a:pPr lvl="4"/>
@@ -2222,6 +2221,7 @@
               <a:rPr lang="en-US" smtClean="0"/>
               <a:t>Click to edit Master text styles</a:t>
             </a:r>
+            <a:endParaRPr lang="en-US" smtClean="0"/>
           </a:p>
         </p:txBody>
       </p:sp>
@@ -2242,8 +2242,6 @@
           <a:p>
             <a:fld id="{1D8BD707-D9CF-40AE-B4C6-C98DA3205C09}" type="datetimeFigureOut">
               <a:rPr lang="en-US" smtClean="0"/>
-              <a:pPr/>
-              <a:t>8/1/2011</a:t>
             </a:fld>
             <a:endParaRPr lang="en-US"/>
           </a:p>
@@ -2285,8 +2283,6 @@
           <a:p>
             <a:fld id="{B6F15528-21DE-4FAA-801E-634DDDAF4B2B}" type="slidenum">
               <a:rPr lang="en-US" smtClean="0"/>
-              <a:pPr/>
-              <a:t>‹#›</a:t>
             </a:fld>
             <a:endParaRPr lang="en-US"/>
           </a:p>
@@ -2472,6 +2468,7 @@
               <a:rPr lang="en-US" smtClean="0"/>
               <a:t>Click to edit Master text styles</a:t>
             </a:r>
+            <a:endParaRPr lang="en-US" smtClean="0"/>
           </a:p>
         </p:txBody>
       </p:sp>
@@ -2492,8 +2489,6 @@
           <a:p>
             <a:fld id="{1D8BD707-D9CF-40AE-B4C6-C98DA3205C09}" type="datetimeFigureOut">
               <a:rPr lang="en-US" smtClean="0"/>
-              <a:pPr/>
-              <a:t>8/1/2011</a:t>
             </a:fld>
             <a:endParaRPr lang="en-US"/>
           </a:p>
@@ -2535,8 +2530,6 @@
           <a:p>
             <a:fld id="{B6F15528-21DE-4FAA-801E-634DDDAF4B2B}" type="slidenum">
               <a:rPr lang="en-US" smtClean="0"/>
-              <a:pPr/>
-              <a:t>‹#›</a:t>
             </a:fld>
             <a:endParaRPr lang="en-US"/>
           </a:p>
@@ -2635,6 +2628,7 @@
               <a:rPr lang="en-US" smtClean="0"/>
               <a:t>Click to edit Master text styles</a:t>
             </a:r>
+            <a:endParaRPr lang="en-US" smtClean="0"/>
           </a:p>
           <a:p>
             <a:pPr lvl="1"/>
@@ -2642,6 +2636,7 @@
               <a:rPr lang="en-US" smtClean="0"/>
               <a:t>Second level</a:t>
             </a:r>
+            <a:endParaRPr lang="en-US" smtClean="0"/>
           </a:p>
           <a:p>
             <a:pPr lvl="2"/>
@@ -2649,6 +2644,7 @@
               <a:rPr lang="en-US" smtClean="0"/>
               <a:t>Third level</a:t>
             </a:r>
+            <a:endParaRPr lang="en-US" smtClean="0"/>
           </a:p>
           <a:p>
             <a:pPr lvl="3"/>
@@ -2656,6 +2652,7 @@
               <a:rPr lang="en-US" smtClean="0"/>
               <a:t>Fourth level</a:t>
             </a:r>
+            <a:endParaRPr lang="en-US" smtClean="0"/>
           </a:p>
           <a:p>
             <a:pPr lvl="4"/>
@@ -2702,8 +2699,6 @@
           <a:p>
             <a:fld id="{1D8BD707-D9CF-40AE-B4C6-C98DA3205C09}" type="datetimeFigureOut">
               <a:rPr lang="en-US" smtClean="0"/>
-              <a:pPr/>
-              <a:t>8/1/2011</a:t>
             </a:fld>
             <a:endParaRPr lang="en-US"/>
           </a:p>
@@ -2781,8 +2776,6 @@
           <a:p>
             <a:fld id="{B6F15528-21DE-4FAA-801E-634DDDAF4B2B}" type="slidenum">
               <a:rPr lang="en-US" smtClean="0"/>
-              <a:pPr/>
-              <a:t>‹#›</a:t>
             </a:fld>
             <a:endParaRPr lang="en-US"/>
           </a:p>
@@ -2826,7 +2819,7 @@
         <a:spcBef>
           <a:spcPct val="20000"/>
         </a:spcBef>
-        <a:buFont typeface="Arial" pitchFamily="34" charset="0"/>
+        <a:buFont typeface="Arial" panose="020B0604020202020204" pitchFamily="34" charset="0"/>
         <a:buChar char="•"/>
         <a:defRPr sz="3200" kern="1200">
           <a:solidFill>
@@ -2841,7 +2834,7 @@
         <a:spcBef>
           <a:spcPct val="20000"/>
         </a:spcBef>
-        <a:buFont typeface="Arial" pitchFamily="34" charset="0"/>
+        <a:buFont typeface="Arial" panose="020B0604020202020204" pitchFamily="34" charset="0"/>
         <a:buChar char="–"/>
         <a:defRPr sz="2800" kern="1200">
           <a:solidFill>
@@ -2856,7 +2849,7 @@
         <a:spcBef>
           <a:spcPct val="20000"/>
         </a:spcBef>
-        <a:buFont typeface="Arial" pitchFamily="34" charset="0"/>
+        <a:buFont typeface="Arial" panose="020B0604020202020204" pitchFamily="34" charset="0"/>
         <a:buChar char="•"/>
         <a:defRPr sz="2400" kern="1200">
           <a:solidFill>
@@ -2871,7 +2864,7 @@
         <a:spcBef>
           <a:spcPct val="20000"/>
         </a:spcBef>
-        <a:buFont typeface="Arial" pitchFamily="34" charset="0"/>
+        <a:buFont typeface="Arial" panose="020B0604020202020204" pitchFamily="34" charset="0"/>
         <a:buChar char="–"/>
         <a:defRPr sz="2000" kern="1200">
           <a:solidFill>
@@ -2886,7 +2879,7 @@
         <a:spcBef>
           <a:spcPct val="20000"/>
         </a:spcBef>
-        <a:buFont typeface="Arial" pitchFamily="34" charset="0"/>
+        <a:buFont typeface="Arial" panose="020B0604020202020204" pitchFamily="34" charset="0"/>
         <a:buChar char="»"/>
         <a:defRPr sz="2000" kern="1200">
           <a:solidFill>
@@ -2901,7 +2894,7 @@
         <a:spcBef>
           <a:spcPct val="20000"/>
         </a:spcBef>
-        <a:buFont typeface="Arial" pitchFamily="34" charset="0"/>
+        <a:buFont typeface="Arial" panose="020B0604020202020204" pitchFamily="34" charset="0"/>
         <a:buChar char="•"/>
         <a:defRPr sz="2000" kern="1200">
           <a:solidFill>
@@ -2916,7 +2909,7 @@
         <a:spcBef>
           <a:spcPct val="20000"/>
         </a:spcBef>
-        <a:buFont typeface="Arial" pitchFamily="34" charset="0"/>
+        <a:buFont typeface="Arial" panose="020B0604020202020204" pitchFamily="34" charset="0"/>
         <a:buChar char="•"/>
         <a:defRPr sz="2000" kern="1200">
           <a:solidFill>
@@ -2931,7 +2924,7 @@
         <a:spcBef>
           <a:spcPct val="20000"/>
         </a:spcBef>
-        <a:buFont typeface="Arial" pitchFamily="34" charset="0"/>
+        <a:buFont typeface="Arial" panose="020B0604020202020204" pitchFamily="34" charset="0"/>
         <a:buChar char="•"/>
         <a:defRPr sz="2000" kern="1200">
           <a:solidFill>
@@ -2946,7 +2939,7 @@
         <a:spcBef>
           <a:spcPct val="20000"/>
         </a:spcBef>
-        <a:buFont typeface="Arial" pitchFamily="34" charset="0"/>
+        <a:buFont typeface="Arial" panose="020B0604020202020204" pitchFamily="34" charset="0"/>
         <a:buChar char="•"/>
         <a:defRPr sz="2000" kern="1200">
           <a:solidFill>
@@ -3058,7 +3051,7 @@
 </file>
 
 <file path=ppt/slides/slide1.xml><?xml version="1.0" encoding="utf-8"?>
-<p:sld xmlns:p="http://schemas.openxmlformats.org/presentationml/2006/main" xmlns:a="http://schemas.openxmlformats.org/drawingml/2006/main">
+<p:sld xmlns:a="http://schemas.openxmlformats.org/drawingml/2006/main" xmlns:r="http://schemas.openxmlformats.org/officeDocument/2006/relationships" xmlns:p="http://schemas.openxmlformats.org/presentationml/2006/main">
   <p:cSld>
     <p:spTree>
       <p:nvGrpSpPr>
@@ -3076,12 +3069,12 @@
       </p:grpSpPr>
       <p:sp>
         <p:nvSpPr>
-          <p:cNvPr name="TextBox 2" id="2"/>
-          <p:cNvSpPr txBox="true"/>
+          <p:cNvPr id="2" name="TextBox 2"/>
+          <p:cNvSpPr txBox="1"/>
           <p:nvPr/>
         </p:nvSpPr>
         <p:spPr>
-          <a:xfrm rot="0">
+          <a:xfrm>
             <a:off x="5681662" y="2429510"/>
             <a:ext cx="6820732" cy="1813566"/>
           </a:xfrm>
@@ -3090,21 +3083,21 @@
           </a:prstGeom>
         </p:spPr>
         <p:txBody>
-          <a:bodyPr anchor="t" rtlCol="false" tIns="0" lIns="0" bIns="0" rIns="0">
+          <a:bodyPr lIns="0" tIns="0" rIns="0" bIns="0" rtlCol="0" anchor="t">
             <a:spAutoFit/>
           </a:bodyPr>
           <a:lstStyle/>
           <a:p>
             <a:pPr algn="ctr">
               <a:lnSpc>
-                <a:spcPts val="14844"/>
+                <a:spcPts val="14845"/>
               </a:lnSpc>
               <a:spcBef>
                 <a:spcPct val="0"/>
               </a:spcBef>
             </a:pPr>
             <a:r>
-              <a:rPr lang="en-US" b="true" sz="10603">
+              <a:rPr lang="en-US" sz="10605" b="1">
                 <a:solidFill>
                   <a:srgbClr val="FF8A00"/>
                 </a:solidFill>
@@ -3115,17 +3108,26 @@
               </a:rPr>
               <a:t>EasyColoc</a:t>
             </a:r>
-          </a:p>
-        </p:txBody>
-      </p:sp>
-      <p:sp>
-        <p:nvSpPr>
-          <p:cNvPr name="TextBox 3" id="3"/>
-          <p:cNvSpPr txBox="true"/>
+            <a:endParaRPr lang="en-US" sz="10605" b="1">
+              <a:solidFill>
+                <a:srgbClr val="FF8A00"/>
+              </a:solidFill>
+              <a:latin typeface="Canva Sans Bold"/>
+              <a:ea typeface="Canva Sans Bold"/>
+              <a:cs typeface="Canva Sans Bold"/>
+              <a:sym typeface="Canva Sans Bold"/>
+            </a:endParaRPr>
+          </a:p>
+        </p:txBody>
+      </p:sp>
+      <p:sp>
+        <p:nvSpPr>
+          <p:cNvPr id="3" name="TextBox 3"/>
+          <p:cNvSpPr txBox="1"/>
           <p:nvPr/>
         </p:nvSpPr>
         <p:spPr>
-          <a:xfrm rot="0">
+          <a:xfrm>
             <a:off x="2740184" y="4595812"/>
             <a:ext cx="12807632" cy="854076"/>
           </a:xfrm>
@@ -3134,21 +3136,21 @@
           </a:prstGeom>
         </p:spPr>
         <p:txBody>
-          <a:bodyPr anchor="t" rtlCol="false" tIns="0" lIns="0" bIns="0" rIns="0">
+          <a:bodyPr lIns="0" tIns="0" rIns="0" bIns="0" rtlCol="0" anchor="t">
             <a:spAutoFit/>
           </a:bodyPr>
           <a:lstStyle/>
           <a:p>
             <a:pPr algn="ctr">
               <a:lnSpc>
-                <a:spcPts val="6999"/>
+                <a:spcPts val="7000"/>
               </a:lnSpc>
               <a:spcBef>
                 <a:spcPct val="0"/>
               </a:spcBef>
             </a:pPr>
             <a:r>
-              <a:rPr lang="en-US" sz="4999">
+              <a:rPr lang="en-US" sz="5000">
                 <a:solidFill>
                   <a:srgbClr val="000000"/>
                 </a:solidFill>
@@ -3160,7 +3162,7 @@
               <a:t>Sm</a:t>
             </a:r>
             <a:r>
-              <a:rPr lang="en-US" sz="4999">
+              <a:rPr lang="en-US" sz="5000">
                 <a:solidFill>
                   <a:srgbClr val="000000"/>
                 </a:solidFill>
@@ -3171,17 +3173,26 @@
               </a:rPr>
               <a:t>arter Roommate Expense Management</a:t>
             </a:r>
-          </a:p>
-        </p:txBody>
-      </p:sp>
-      <p:sp>
-        <p:nvSpPr>
-          <p:cNvPr name="TextBox 4" id="4"/>
-          <p:cNvSpPr txBox="true"/>
+            <a:endParaRPr lang="en-US" sz="5000">
+              <a:solidFill>
+                <a:srgbClr val="000000"/>
+              </a:solidFill>
+              <a:latin typeface="Canva Sans"/>
+              <a:ea typeface="Canva Sans"/>
+              <a:cs typeface="Canva Sans"/>
+              <a:sym typeface="Canva Sans"/>
+            </a:endParaRPr>
+          </a:p>
+        </p:txBody>
+      </p:sp>
+      <p:sp>
+        <p:nvSpPr>
+          <p:cNvPr id="4" name="TextBox 4"/>
+          <p:cNvSpPr txBox="1"/>
           <p:nvPr/>
         </p:nvSpPr>
         <p:spPr>
-          <a:xfrm rot="0">
+          <a:xfrm>
             <a:off x="8362633" y="5964238"/>
             <a:ext cx="1562735" cy="580390"/>
           </a:xfrm>
@@ -3190,18 +3201,18 @@
           </a:prstGeom>
         </p:spPr>
         <p:txBody>
-          <a:bodyPr anchor="t" rtlCol="false" tIns="0" lIns="0" bIns="0" rIns="0">
+          <a:bodyPr lIns="0" tIns="0" rIns="0" bIns="0" rtlCol="0" anchor="t">
             <a:spAutoFit/>
           </a:bodyPr>
           <a:lstStyle/>
           <a:p>
             <a:pPr algn="ctr">
               <a:lnSpc>
-                <a:spcPts val="4759"/>
+                <a:spcPts val="4760"/>
               </a:lnSpc>
             </a:pPr>
             <a:r>
-              <a:rPr lang="en-US" sz="3399">
+              <a:rPr lang="en-US" sz="3400">
                 <a:solidFill>
                   <a:srgbClr val="000000"/>
                 </a:solidFill>
@@ -3212,6 +3223,15 @@
               </a:rPr>
               <a:t>Ali Kara</a:t>
             </a:r>
+            <a:endParaRPr lang="en-US" sz="3400">
+              <a:solidFill>
+                <a:srgbClr val="000000"/>
+              </a:solidFill>
+              <a:latin typeface="Canva Sans"/>
+              <a:ea typeface="Canva Sans"/>
+              <a:cs typeface="Canva Sans"/>
+              <a:sym typeface="Canva Sans"/>
+            </a:endParaRPr>
           </a:p>
         </p:txBody>
       </p:sp>
@@ -3224,7 +3244,7 @@
 </file>
 
 <file path=ppt/slides/slide2.xml><?xml version="1.0" encoding="utf-8"?>
-<p:sld xmlns:p="http://schemas.openxmlformats.org/presentationml/2006/main" xmlns:a="http://schemas.openxmlformats.org/drawingml/2006/main">
+<p:sld xmlns:a="http://schemas.openxmlformats.org/drawingml/2006/main" xmlns:r="http://schemas.openxmlformats.org/officeDocument/2006/relationships" xmlns:p="http://schemas.openxmlformats.org/presentationml/2006/main">
   <p:cSld>
     <p:spTree>
       <p:nvGrpSpPr>
@@ -3242,12 +3262,12 @@
       </p:grpSpPr>
       <p:sp>
         <p:nvSpPr>
-          <p:cNvPr name="TextBox 2" id="2"/>
-          <p:cNvSpPr txBox="true"/>
+          <p:cNvPr id="2" name="TextBox 2"/>
+          <p:cNvSpPr txBox="1"/>
           <p:nvPr/>
         </p:nvSpPr>
         <p:spPr>
-          <a:xfrm rot="0">
+          <a:xfrm>
             <a:off x="5554900" y="681037"/>
             <a:ext cx="7178199" cy="1009652"/>
           </a:xfrm>
@@ -3256,21 +3276,21 @@
           </a:prstGeom>
         </p:spPr>
         <p:txBody>
-          <a:bodyPr anchor="t" rtlCol="false" tIns="0" lIns="0" bIns="0" rIns="0">
+          <a:bodyPr lIns="0" tIns="0" rIns="0" bIns="0" rtlCol="0" anchor="t">
             <a:spAutoFit/>
           </a:bodyPr>
           <a:lstStyle/>
           <a:p>
             <a:pPr algn="ctr">
               <a:lnSpc>
-                <a:spcPts val="8399"/>
+                <a:spcPts val="8400"/>
               </a:lnSpc>
               <a:spcBef>
                 <a:spcPct val="0"/>
               </a:spcBef>
             </a:pPr>
             <a:r>
-              <a:rPr lang="en-US" b="true" sz="5999">
+              <a:rPr lang="en-US" sz="6000" b="1">
                 <a:solidFill>
                   <a:srgbClr val="FF8A00"/>
                 </a:solidFill>
@@ -3282,7 +3302,7 @@
               <a:t>Pr</a:t>
             </a:r>
             <a:r>
-              <a:rPr lang="en-US" b="true" sz="5999">
+              <a:rPr lang="en-US" sz="6000" b="1">
                 <a:solidFill>
                   <a:srgbClr val="FF8A00"/>
                 </a:solidFill>
@@ -3293,17 +3313,26 @@
               </a:rPr>
               <a:t>oblem &amp; Solution</a:t>
             </a:r>
-          </a:p>
-        </p:txBody>
-      </p:sp>
-      <p:sp>
-        <p:nvSpPr>
-          <p:cNvPr name="TextBox 3" id="3"/>
-          <p:cNvSpPr txBox="true"/>
+            <a:endParaRPr lang="en-US" sz="6000" b="1">
+              <a:solidFill>
+                <a:srgbClr val="FF8A00"/>
+              </a:solidFill>
+              <a:latin typeface="Canva Sans Bold"/>
+              <a:ea typeface="Canva Sans Bold"/>
+              <a:cs typeface="Canva Sans Bold"/>
+              <a:sym typeface="Canva Sans Bold"/>
+            </a:endParaRPr>
+          </a:p>
+        </p:txBody>
+      </p:sp>
+      <p:sp>
+        <p:nvSpPr>
+          <p:cNvPr id="3" name="TextBox 3"/>
+          <p:cNvSpPr txBox="1"/>
           <p:nvPr/>
         </p:nvSpPr>
         <p:spPr>
-          <a:xfrm rot="0">
+          <a:xfrm>
             <a:off x="285750" y="3757612"/>
             <a:ext cx="7762246" cy="2794001"/>
           </a:xfrm>
@@ -3312,21 +3341,21 @@
           </a:prstGeom>
         </p:spPr>
         <p:txBody>
-          <a:bodyPr anchor="t" rtlCol="false" tIns="0" lIns="0" bIns="0" rIns="0">
+          <a:bodyPr lIns="0" tIns="0" rIns="0" bIns="0" rtlCol="0" anchor="t">
             <a:spAutoFit/>
           </a:bodyPr>
           <a:lstStyle/>
           <a:p>
             <a:pPr algn="ctr">
               <a:lnSpc>
-                <a:spcPts val="5599"/>
+                <a:spcPts val="5600"/>
               </a:lnSpc>
               <a:spcBef>
                 <a:spcPct val="0"/>
               </a:spcBef>
             </a:pPr>
             <a:r>
-              <a:rPr lang="en-US" b="true" sz="3999">
+              <a:rPr lang="en-US" sz="4000" b="1">
                 <a:solidFill>
                   <a:srgbClr val="000000"/>
                 </a:solidFill>
@@ -3338,7 +3367,7 @@
               <a:t>Calc</a:t>
             </a:r>
             <a:r>
-              <a:rPr lang="en-US" b="true" sz="3999">
+              <a:rPr lang="en-US" sz="4000" b="1">
                 <a:solidFill>
                   <a:srgbClr val="000000"/>
                 </a:solidFill>
@@ -3349,17 +3378,26 @@
               </a:rPr>
               <a:t>ulating shared household expenses manually is tedious, error-prone, and often leads to conflicts among roommates.</a:t>
             </a:r>
-          </a:p>
-        </p:txBody>
-      </p:sp>
-      <p:sp>
-        <p:nvSpPr>
-          <p:cNvPr name="TextBox 4" id="4"/>
-          <p:cNvSpPr txBox="true"/>
+            <a:endParaRPr lang="en-US" sz="4000" b="1">
+              <a:solidFill>
+                <a:srgbClr val="000000"/>
+              </a:solidFill>
+              <a:latin typeface="Canva Sans Bold"/>
+              <a:ea typeface="Canva Sans Bold"/>
+              <a:cs typeface="Canva Sans Bold"/>
+              <a:sym typeface="Canva Sans Bold"/>
+            </a:endParaRPr>
+          </a:p>
+        </p:txBody>
+      </p:sp>
+      <p:sp>
+        <p:nvSpPr>
+          <p:cNvPr id="4" name="TextBox 4"/>
+          <p:cNvSpPr txBox="1"/>
           <p:nvPr/>
         </p:nvSpPr>
         <p:spPr>
-          <a:xfrm rot="0">
+          <a:xfrm>
             <a:off x="9389027" y="3719512"/>
             <a:ext cx="7857496" cy="4203701"/>
           </a:xfrm>
@@ -3368,21 +3406,21 @@
           </a:prstGeom>
         </p:spPr>
         <p:txBody>
-          <a:bodyPr anchor="t" rtlCol="false" tIns="0" lIns="0" bIns="0" rIns="0">
+          <a:bodyPr lIns="0" tIns="0" rIns="0" bIns="0" rtlCol="0" anchor="t">
             <a:spAutoFit/>
           </a:bodyPr>
           <a:lstStyle/>
           <a:p>
             <a:pPr algn="ctr">
               <a:lnSpc>
-                <a:spcPts val="5599"/>
+                <a:spcPts val="5600"/>
               </a:lnSpc>
               <a:spcBef>
                 <a:spcPct val="0"/>
               </a:spcBef>
             </a:pPr>
             <a:r>
-              <a:rPr lang="en-US" b="true" sz="3999">
+              <a:rPr lang="en-US" sz="4000" b="1">
                 <a:solidFill>
                   <a:srgbClr val="000000"/>
                 </a:solidFill>
@@ -3394,7 +3432,7 @@
               <a:t>EasyColoc is a web applic</a:t>
             </a:r>
             <a:r>
-              <a:rPr lang="en-US" b="true" sz="3999">
+              <a:rPr lang="en-US" sz="4000" b="1">
                 <a:solidFill>
                   <a:srgbClr val="000000"/>
                 </a:solidFill>
@@ -3405,6 +3443,15 @@
               </a:rPr>
               <a:t>ation that automatically tracks shared expenses, instantly calculates who owes whom, and enforces financial accountability.</a:t>
             </a:r>
+            <a:endParaRPr lang="en-US" sz="4000" b="1">
+              <a:solidFill>
+                <a:srgbClr val="000000"/>
+              </a:solidFill>
+              <a:latin typeface="Canva Sans Bold"/>
+              <a:ea typeface="Canva Sans Bold"/>
+              <a:cs typeface="Canva Sans Bold"/>
+              <a:sym typeface="Canva Sans Bold"/>
+            </a:endParaRPr>
           </a:p>
         </p:txBody>
       </p:sp>
@@ -3413,14 +3460,14 @@
   <p:clrMapOvr>
     <a:masterClrMapping/>
   </p:clrMapOvr>
-  <p:transition spd="fast">
-    <p:push dir="l"/>
+  <p:transition>
+    <p:push/>
   </p:transition>
 </p:sld>
 </file>
 
 <file path=ppt/slides/slide3.xml><?xml version="1.0" encoding="utf-8"?>
-<p:sld xmlns:p="http://schemas.openxmlformats.org/presentationml/2006/main" xmlns:a="http://schemas.openxmlformats.org/drawingml/2006/main" xmlns:r="http://schemas.openxmlformats.org/officeDocument/2006/relationships">
+<p:sld xmlns:a="http://schemas.openxmlformats.org/drawingml/2006/main" xmlns:r="http://schemas.openxmlformats.org/officeDocument/2006/relationships" xmlns:p="http://schemas.openxmlformats.org/presentationml/2006/main">
   <p:cSld>
     <p:spTree>
       <p:nvGrpSpPr>
@@ -3438,12 +3485,12 @@
       </p:grpSpPr>
       <p:sp>
         <p:nvSpPr>
-          <p:cNvPr name="Freeform 2" id="2"/>
+          <p:cNvPr id="2" name="Freeform 2"/>
           <p:cNvSpPr/>
           <p:nvPr/>
         </p:nvSpPr>
         <p:spPr>
-          <a:xfrm flipH="false" flipV="false" rot="0">
+          <a:xfrm>
             <a:off x="2427578" y="4038452"/>
             <a:ext cx="2766718" cy="2766718"/>
           </a:xfrm>
@@ -3452,9 +3499,9 @@
             <a:gdLst/>
             <a:ahLst/>
             <a:cxnLst/>
-            <a:rect r="r" b="b" t="t" l="l"/>
+            <a:rect l="l" t="t" r="r" b="b"/>
             <a:pathLst>
-              <a:path h="2766718" w="2766718">
+              <a:path w="2766718" h="2766718">
                 <a:moveTo>
                   <a:pt x="0" y="0"/>
                 </a:moveTo>
@@ -3475,21 +3522,21 @@
             </a:pathLst>
           </a:custGeom>
           <a:blipFill>
-            <a:blip r:embed="rId2"/>
+            <a:blip r:embed="rId1"/>
             <a:stretch>
-              <a:fillRect l="0" t="0" r="0" b="0"/>
+              <a:fillRect/>
             </a:stretch>
           </a:blipFill>
         </p:spPr>
       </p:sp>
       <p:sp>
         <p:nvSpPr>
-          <p:cNvPr name="Freeform 3" id="3"/>
+          <p:cNvPr id="3" name="Freeform 3"/>
           <p:cNvSpPr/>
           <p:nvPr/>
         </p:nvSpPr>
         <p:spPr>
-          <a:xfrm flipH="false" flipV="false" rot="0">
+          <a:xfrm>
             <a:off x="6198709" y="4419542"/>
             <a:ext cx="3277174" cy="2004538"/>
           </a:xfrm>
@@ -3498,9 +3545,9 @@
             <a:gdLst/>
             <a:ahLst/>
             <a:cxnLst/>
-            <a:rect r="r" b="b" t="t" l="l"/>
+            <a:rect l="l" t="t" r="r" b="b"/>
             <a:pathLst>
-              <a:path h="2004538" w="3277174">
+              <a:path w="3277174" h="2004538">
                 <a:moveTo>
                   <a:pt x="0" y="0"/>
                 </a:moveTo>
@@ -3521,21 +3568,21 @@
             </a:pathLst>
           </a:custGeom>
           <a:blipFill>
-            <a:blip r:embed="rId3"/>
+            <a:blip r:embed="rId2"/>
             <a:stretch>
-              <a:fillRect l="0" t="0" r="0" b="0"/>
+              <a:fillRect/>
             </a:stretch>
           </a:blipFill>
         </p:spPr>
       </p:sp>
       <p:sp>
         <p:nvSpPr>
-          <p:cNvPr name="Freeform 4" id="4"/>
+          <p:cNvPr id="4" name="Freeform 4"/>
           <p:cNvSpPr/>
           <p:nvPr/>
         </p:nvSpPr>
         <p:spPr>
-          <a:xfrm flipH="false" flipV="false" rot="0">
+          <a:xfrm>
             <a:off x="10476008" y="4167468"/>
             <a:ext cx="2571123" cy="2508687"/>
           </a:xfrm>
@@ -3544,9 +3591,9 @@
             <a:gdLst/>
             <a:ahLst/>
             <a:cxnLst/>
-            <a:rect r="r" b="b" t="t" l="l"/>
+            <a:rect l="l" t="t" r="r" b="b"/>
             <a:pathLst>
-              <a:path h="2508687" w="2571123">
+              <a:path w="2571123" h="2508687">
                 <a:moveTo>
                   <a:pt x="0" y="0"/>
                 </a:moveTo>
@@ -3567,21 +3614,21 @@
             </a:pathLst>
           </a:custGeom>
           <a:blipFill>
-            <a:blip r:embed="rId4"/>
+            <a:blip r:embed="rId3"/>
             <a:stretch>
-              <a:fillRect l="0" t="0" r="-137467" b="0"/>
+              <a:fillRect r="-137467"/>
             </a:stretch>
           </a:blipFill>
         </p:spPr>
       </p:sp>
       <p:sp>
         <p:nvSpPr>
-          <p:cNvPr name="Freeform 5" id="5"/>
+          <p:cNvPr id="5" name="Freeform 5"/>
           <p:cNvSpPr/>
           <p:nvPr/>
         </p:nvSpPr>
         <p:spPr>
-          <a:xfrm flipH="false" flipV="false" rot="0">
+          <a:xfrm>
             <a:off x="14264243" y="4167468"/>
             <a:ext cx="2453198" cy="2508687"/>
           </a:xfrm>
@@ -3590,9 +3637,9 @@
             <a:gdLst/>
             <a:ahLst/>
             <a:cxnLst/>
-            <a:rect r="r" b="b" t="t" l="l"/>
+            <a:rect l="l" t="t" r="r" b="b"/>
             <a:pathLst>
-              <a:path h="2508687" w="2453198">
+              <a:path w="2453198" h="2508687">
                 <a:moveTo>
                   <a:pt x="0" y="0"/>
                 </a:moveTo>
@@ -3613,21 +3660,21 @@
             </a:pathLst>
           </a:custGeom>
           <a:blipFill>
-            <a:blip r:embed="rId5"/>
+            <a:blip r:embed="rId4"/>
             <a:stretch>
-              <a:fillRect l="0" t="0" r="0" b="0"/>
+              <a:fillRect/>
             </a:stretch>
           </a:blipFill>
         </p:spPr>
       </p:sp>
       <p:sp>
         <p:nvSpPr>
-          <p:cNvPr name="TextBox 6" id="6"/>
-          <p:cNvSpPr txBox="true"/>
+          <p:cNvPr id="6" name="TextBox 6"/>
+          <p:cNvSpPr txBox="1"/>
           <p:nvPr/>
         </p:nvSpPr>
         <p:spPr>
-          <a:xfrm rot="0">
+          <a:xfrm>
             <a:off x="7153196" y="1252537"/>
             <a:ext cx="3981609" cy="1009652"/>
           </a:xfrm>
@@ -3636,21 +3683,21 @@
           </a:prstGeom>
         </p:spPr>
         <p:txBody>
-          <a:bodyPr anchor="t" rtlCol="false" tIns="0" lIns="0" bIns="0" rIns="0">
+          <a:bodyPr lIns="0" tIns="0" rIns="0" bIns="0" rtlCol="0" anchor="t">
             <a:spAutoFit/>
           </a:bodyPr>
           <a:lstStyle/>
           <a:p>
             <a:pPr algn="ctr">
               <a:lnSpc>
-                <a:spcPts val="8399"/>
+                <a:spcPts val="8400"/>
               </a:lnSpc>
               <a:spcBef>
                 <a:spcPct val="0"/>
               </a:spcBef>
             </a:pPr>
             <a:r>
-              <a:rPr lang="en-US" b="true" sz="5999">
+              <a:rPr lang="en-US" sz="6000" b="1">
                 <a:solidFill>
                   <a:srgbClr val="FF8A00"/>
                 </a:solidFill>
@@ -3662,7 +3709,7 @@
               <a:t>Tec</a:t>
             </a:r>
             <a:r>
-              <a:rPr lang="en-US" b="true" sz="5999">
+              <a:rPr lang="en-US" sz="6000" b="1">
                 <a:solidFill>
                   <a:srgbClr val="FF8A00"/>
                 </a:solidFill>
@@ -3673,17 +3720,26 @@
               </a:rPr>
               <a:t>h Stack</a:t>
             </a:r>
-          </a:p>
-        </p:txBody>
-      </p:sp>
-      <p:sp>
-        <p:nvSpPr>
-          <p:cNvPr name="TextBox 7" id="7"/>
-          <p:cNvSpPr txBox="true"/>
+            <a:endParaRPr lang="en-US" sz="6000" b="1">
+              <a:solidFill>
+                <a:srgbClr val="FF8A00"/>
+              </a:solidFill>
+              <a:latin typeface="Canva Sans Bold"/>
+              <a:ea typeface="Canva Sans Bold"/>
+              <a:cs typeface="Canva Sans Bold"/>
+              <a:sym typeface="Canva Sans Bold"/>
+            </a:endParaRPr>
+          </a:p>
+        </p:txBody>
+      </p:sp>
+      <p:sp>
+        <p:nvSpPr>
+          <p:cNvPr id="7" name="TextBox 7"/>
+          <p:cNvSpPr txBox="1"/>
           <p:nvPr/>
         </p:nvSpPr>
         <p:spPr>
-          <a:xfrm rot="0">
+          <a:xfrm>
             <a:off x="8074660" y="7539037"/>
             <a:ext cx="2138680" cy="1009652"/>
           </a:xfrm>
@@ -3692,21 +3748,21 @@
           </a:prstGeom>
         </p:spPr>
         <p:txBody>
-          <a:bodyPr anchor="t" rtlCol="false" tIns="0" lIns="0" bIns="0" rIns="0">
+          <a:bodyPr lIns="0" tIns="0" rIns="0" bIns="0" rtlCol="0" anchor="t">
             <a:spAutoFit/>
           </a:bodyPr>
           <a:lstStyle/>
           <a:p>
             <a:pPr algn="ctr">
               <a:lnSpc>
-                <a:spcPts val="8399"/>
+                <a:spcPts val="8400"/>
               </a:lnSpc>
               <a:spcBef>
                 <a:spcPct val="0"/>
               </a:spcBef>
             </a:pPr>
             <a:r>
-              <a:rPr lang="en-US" b="true" sz="5999">
+              <a:rPr lang="en-US" sz="6000" b="1">
                 <a:solidFill>
                   <a:srgbClr val="FF8A00"/>
                 </a:solidFill>
@@ -3717,6 +3773,15 @@
               </a:rPr>
               <a:t>Blade</a:t>
             </a:r>
+            <a:endParaRPr lang="en-US" sz="6000" b="1">
+              <a:solidFill>
+                <a:srgbClr val="FF8A00"/>
+              </a:solidFill>
+              <a:latin typeface="Canva Sans Bold"/>
+              <a:ea typeface="Canva Sans Bold"/>
+              <a:cs typeface="Canva Sans Bold"/>
+              <a:sym typeface="Canva Sans Bold"/>
+            </a:endParaRPr>
           </a:p>
         </p:txBody>
       </p:sp>
@@ -3725,14 +3790,14 @@
   <p:clrMapOvr>
     <a:masterClrMapping/>
   </p:clrMapOvr>
-  <p:transition spd="fast">
-    <p:push dir="l"/>
+  <p:transition>
+    <p:push/>
   </p:transition>
 </p:sld>
 </file>
 
 <file path=ppt/slides/slide4.xml><?xml version="1.0" encoding="utf-8"?>
-<p:sld xmlns:p="http://schemas.openxmlformats.org/presentationml/2006/main" xmlns:a="http://schemas.openxmlformats.org/drawingml/2006/main" xmlns:r="http://schemas.openxmlformats.org/officeDocument/2006/relationships">
+<p:sld xmlns:a="http://schemas.openxmlformats.org/drawingml/2006/main" xmlns:r="http://schemas.openxmlformats.org/officeDocument/2006/relationships" xmlns:p="http://schemas.openxmlformats.org/presentationml/2006/main">
   <p:cSld>
     <p:spTree>
       <p:nvGrpSpPr>
@@ -3750,58 +3815,12 @@
       </p:grpSpPr>
       <p:sp>
         <p:nvSpPr>
-          <p:cNvPr name="Freeform 2" id="2"/>
-          <p:cNvSpPr/>
+          <p:cNvPr id="3" name="TextBox 3"/>
+          <p:cNvSpPr txBox="1"/>
           <p:nvPr/>
         </p:nvSpPr>
         <p:spPr>
-          <a:xfrm flipH="false" flipV="false" rot="0">
-            <a:off x="10465366" y="282567"/>
-            <a:ext cx="7512351" cy="9721866"/>
-          </a:xfrm>
-          <a:custGeom>
-            <a:avLst/>
-            <a:gdLst/>
-            <a:ahLst/>
-            <a:cxnLst/>
-            <a:rect r="r" b="b" t="t" l="l"/>
-            <a:pathLst>
-              <a:path h="9721866" w="7512351">
-                <a:moveTo>
-                  <a:pt x="0" y="0"/>
-                </a:moveTo>
-                <a:lnTo>
-                  <a:pt x="7512351" y="0"/>
-                </a:lnTo>
-                <a:lnTo>
-                  <a:pt x="7512351" y="9721866"/>
-                </a:lnTo>
-                <a:lnTo>
-                  <a:pt x="0" y="9721866"/>
-                </a:lnTo>
-                <a:lnTo>
-                  <a:pt x="0" y="0"/>
-                </a:lnTo>
-                <a:close/>
-              </a:path>
-            </a:pathLst>
-          </a:custGeom>
-          <a:blipFill>
-            <a:blip r:embed="rId2"/>
-            <a:stretch>
-              <a:fillRect l="0" t="0" r="0" b="0"/>
-            </a:stretch>
-          </a:blipFill>
-        </p:spPr>
-      </p:sp>
-      <p:sp>
-        <p:nvSpPr>
-          <p:cNvPr name="TextBox 3" id="3"/>
-          <p:cNvSpPr txBox="true"/>
-          <p:nvPr/>
-        </p:nvSpPr>
-        <p:spPr>
-          <a:xfrm rot="0">
+          <a:xfrm>
             <a:off x="3357483" y="4586287"/>
             <a:ext cx="3381534" cy="1009652"/>
           </a:xfrm>
@@ -3810,21 +3829,21 @@
           </a:prstGeom>
         </p:spPr>
         <p:txBody>
-          <a:bodyPr anchor="t" rtlCol="false" tIns="0" lIns="0" bIns="0" rIns="0">
+          <a:bodyPr lIns="0" tIns="0" rIns="0" bIns="0" rtlCol="0" anchor="t">
             <a:spAutoFit/>
           </a:bodyPr>
           <a:lstStyle/>
           <a:p>
             <a:pPr algn="ctr">
               <a:lnSpc>
-                <a:spcPts val="8399"/>
+                <a:spcPts val="8400"/>
               </a:lnSpc>
               <a:spcBef>
                 <a:spcPct val="0"/>
               </a:spcBef>
             </a:pPr>
             <a:r>
-              <a:rPr lang="en-US" b="true" sz="5999">
+              <a:rPr lang="en-US" sz="6000" b="1">
                 <a:solidFill>
                   <a:srgbClr val="FF8A00"/>
                 </a:solidFill>
@@ -3835,22 +3854,55 @@
               </a:rPr>
               <a:t>Use-case</a:t>
             </a:r>
-          </a:p>
-        </p:txBody>
-      </p:sp>
+            <a:endParaRPr lang="en-US" sz="6000" b="1">
+              <a:solidFill>
+                <a:srgbClr val="FF8A00"/>
+              </a:solidFill>
+              <a:latin typeface="Canva Sans Bold"/>
+              <a:ea typeface="Canva Sans Bold"/>
+              <a:cs typeface="Canva Sans Bold"/>
+              <a:sym typeface="Canva Sans Bold"/>
+            </a:endParaRPr>
+          </a:p>
+        </p:txBody>
+      </p:sp>
+      <p:pic>
+        <p:nvPicPr>
+          <p:cNvPr id="4" name="Picture 3" descr="useCase"/>
+          <p:cNvPicPr>
+            <a:picLocks noChangeAspect="1"/>
+          </p:cNvPicPr>
+          <p:nvPr/>
+        </p:nvPicPr>
+        <p:blipFill>
+          <a:blip r:embed="rId1"/>
+          <a:stretch>
+            <a:fillRect/>
+          </a:stretch>
+        </p:blipFill>
+        <p:spPr>
+          <a:xfrm>
+            <a:off x="10871835" y="0"/>
+            <a:ext cx="6602095" cy="10287000"/>
+          </a:xfrm>
+          <a:prstGeom prst="rect">
+            <a:avLst/>
+          </a:prstGeom>
+        </p:spPr>
+      </p:pic>
     </p:spTree>
   </p:cSld>
   <p:clrMapOvr>
     <a:masterClrMapping/>
   </p:clrMapOvr>
-  <p:transition spd="fast">
-    <p:push dir="l"/>
+  <p:transition>
+    <p:push/>
   </p:transition>
 </p:sld>
 </file>
 
 <file path=ppt/slides/slide5.xml><?xml version="1.0" encoding="utf-8"?>
-<p:sld xmlns:p="http://schemas.openxmlformats.org/presentationml/2006/main" xmlns:a="http://schemas.openxmlformats.org/drawingml/2006/main" xmlns:r="http://schemas.openxmlformats.org/officeDocument/2006/relationships">
+<p:sld xmlns:a="http://schemas.openxmlformats.org/drawingml/2006/main" xmlns:r="http://schemas.openxmlformats.org/officeDocument/2006/relationships" xmlns:p="http://schemas.openxmlformats.org/presentationml/2006/main">
   <p:cSld>
     <p:spTree>
       <p:nvGrpSpPr>
@@ -3868,12 +3920,12 @@
       </p:grpSpPr>
       <p:sp>
         <p:nvSpPr>
-          <p:cNvPr name="Freeform 2" id="2"/>
+          <p:cNvPr id="2" name="Freeform 2"/>
           <p:cNvSpPr/>
           <p:nvPr/>
         </p:nvSpPr>
         <p:spPr>
-          <a:xfrm flipH="false" flipV="false" rot="0">
+          <a:xfrm>
             <a:off x="6514915" y="807485"/>
             <a:ext cx="11142936" cy="8672030"/>
           </a:xfrm>
@@ -3882,9 +3934,9 @@
             <a:gdLst/>
             <a:ahLst/>
             <a:cxnLst/>
-            <a:rect r="r" b="b" t="t" l="l"/>
+            <a:rect l="l" t="t" r="r" b="b"/>
             <a:pathLst>
-              <a:path h="8672030" w="11142936">
+              <a:path w="11142936" h="8672030">
                 <a:moveTo>
                   <a:pt x="0" y="0"/>
                 </a:moveTo>
@@ -3905,21 +3957,21 @@
             </a:pathLst>
           </a:custGeom>
           <a:blipFill>
-            <a:blip r:embed="rId2"/>
+            <a:blip r:embed="rId1"/>
             <a:stretch>
-              <a:fillRect l="0" t="0" r="0" b="-66284"/>
+              <a:fillRect b="-66284"/>
             </a:stretch>
           </a:blipFill>
         </p:spPr>
       </p:sp>
       <p:sp>
         <p:nvSpPr>
-          <p:cNvPr name="TextBox 3" id="3"/>
-          <p:cNvSpPr txBox="true"/>
+          <p:cNvPr id="3" name="TextBox 3"/>
+          <p:cNvSpPr txBox="1"/>
           <p:nvPr/>
         </p:nvSpPr>
         <p:spPr>
-          <a:xfrm rot="0">
+          <a:xfrm>
             <a:off x="760333" y="4300537"/>
             <a:ext cx="5337334" cy="2066927"/>
           </a:xfrm>
@@ -3928,18 +3980,18 @@
           </a:prstGeom>
         </p:spPr>
         <p:txBody>
-          <a:bodyPr anchor="t" rtlCol="false" tIns="0" lIns="0" bIns="0" rIns="0">
+          <a:bodyPr lIns="0" tIns="0" rIns="0" bIns="0" rtlCol="0" anchor="t">
             <a:spAutoFit/>
           </a:bodyPr>
           <a:lstStyle/>
           <a:p>
             <a:pPr algn="ctr">
               <a:lnSpc>
-                <a:spcPts val="8399"/>
+                <a:spcPts val="8400"/>
               </a:lnSpc>
             </a:pPr>
             <a:r>
-              <a:rPr lang="en-US" b="true" sz="5999">
+              <a:rPr lang="en-US" sz="6000" b="1">
                 <a:solidFill>
                   <a:srgbClr val="FF8A00"/>
                 </a:solidFill>
@@ -3950,18 +4002,27 @@
               </a:rPr>
               <a:t>class-diagram </a:t>
             </a:r>
+            <a:endParaRPr lang="en-US" sz="6000" b="1">
+              <a:solidFill>
+                <a:srgbClr val="FF8A00"/>
+              </a:solidFill>
+              <a:latin typeface="Canva Sans Bold"/>
+              <a:ea typeface="Canva Sans Bold"/>
+              <a:cs typeface="Canva Sans Bold"/>
+              <a:sym typeface="Canva Sans Bold"/>
+            </a:endParaRPr>
           </a:p>
           <a:p>
             <a:pPr algn="ctr">
               <a:lnSpc>
-                <a:spcPts val="8399"/>
+                <a:spcPts val="8400"/>
               </a:lnSpc>
               <a:spcBef>
                 <a:spcPct val="0"/>
               </a:spcBef>
             </a:pPr>
             <a:r>
-              <a:rPr lang="en-US" b="true" sz="5999">
+              <a:rPr lang="en-US" sz="6000" b="1">
                 <a:solidFill>
                   <a:srgbClr val="FF8A00"/>
                 </a:solidFill>
@@ -3972,6 +4033,15 @@
               </a:rPr>
               <a:t>(UML)</a:t>
             </a:r>
+            <a:endParaRPr lang="en-US" sz="6000" b="1">
+              <a:solidFill>
+                <a:srgbClr val="FF8A00"/>
+              </a:solidFill>
+              <a:latin typeface="Canva Sans Bold"/>
+              <a:ea typeface="Canva Sans Bold"/>
+              <a:cs typeface="Canva Sans Bold"/>
+              <a:sym typeface="Canva Sans Bold"/>
+            </a:endParaRPr>
           </a:p>
         </p:txBody>
       </p:sp>
@@ -3980,14 +4050,14 @@
   <p:clrMapOvr>
     <a:masterClrMapping/>
   </p:clrMapOvr>
-  <p:transition spd="fast">
-    <p:push dir="l"/>
+  <p:transition>
+    <p:push/>
   </p:transition>
 </p:sld>
 </file>
 
 <file path=ppt/slides/slide6.xml><?xml version="1.0" encoding="utf-8"?>
-<p:sld xmlns:p="http://schemas.openxmlformats.org/presentationml/2006/main" xmlns:a="http://schemas.openxmlformats.org/drawingml/2006/main">
+<p:sld xmlns:a="http://schemas.openxmlformats.org/drawingml/2006/main" xmlns:r="http://schemas.openxmlformats.org/officeDocument/2006/relationships" xmlns:p="http://schemas.openxmlformats.org/presentationml/2006/main">
   <p:cSld>
     <p:spTree>
       <p:nvGrpSpPr>
@@ -4005,12 +4075,12 @@
       </p:grpSpPr>
       <p:sp>
         <p:nvSpPr>
-          <p:cNvPr name="TextBox 2" id="2"/>
-          <p:cNvSpPr txBox="true"/>
+          <p:cNvPr id="2" name="TextBox 2"/>
+          <p:cNvSpPr txBox="1"/>
           <p:nvPr/>
         </p:nvSpPr>
         <p:spPr>
-          <a:xfrm rot="0">
+          <a:xfrm>
             <a:off x="4682649" y="4586287"/>
             <a:ext cx="8922702" cy="1009652"/>
           </a:xfrm>
@@ -4019,21 +4089,21 @@
           </a:prstGeom>
         </p:spPr>
         <p:txBody>
-          <a:bodyPr anchor="t" rtlCol="false" tIns="0" lIns="0" bIns="0" rIns="0">
+          <a:bodyPr lIns="0" tIns="0" rIns="0" bIns="0" rtlCol="0" anchor="t">
             <a:spAutoFit/>
           </a:bodyPr>
           <a:lstStyle/>
           <a:p>
             <a:pPr algn="ctr">
               <a:lnSpc>
-                <a:spcPts val="8399"/>
+                <a:spcPts val="8400"/>
               </a:lnSpc>
               <a:spcBef>
                 <a:spcPct val="0"/>
               </a:spcBef>
             </a:pPr>
             <a:r>
-              <a:rPr lang="en-US" b="true" sz="5999">
+              <a:rPr lang="en-US" sz="6000" b="1">
                 <a:solidFill>
                   <a:srgbClr val="FF8A00"/>
                 </a:solidFill>
@@ -4045,7 +4115,7 @@
               <a:t>web-site dem</a:t>
             </a:r>
             <a:r>
-              <a:rPr lang="en-US" b="true" sz="5999">
+              <a:rPr lang="en-US" sz="6000" b="1">
                 <a:solidFill>
                   <a:srgbClr val="FF8A00"/>
                 </a:solidFill>
@@ -4056,6 +4126,15 @@
               </a:rPr>
               <a:t>onstration</a:t>
             </a:r>
+            <a:endParaRPr lang="en-US" sz="6000" b="1">
+              <a:solidFill>
+                <a:srgbClr val="FF8A00"/>
+              </a:solidFill>
+              <a:latin typeface="Canva Sans Bold"/>
+              <a:ea typeface="Canva Sans Bold"/>
+              <a:cs typeface="Canva Sans Bold"/>
+              <a:sym typeface="Canva Sans Bold"/>
+            </a:endParaRPr>
           </a:p>
         </p:txBody>
       </p:sp>
@@ -4064,8 +4143,8 @@
   <p:clrMapOvr>
     <a:masterClrMapping/>
   </p:clrMapOvr>
-  <p:transition spd="fast">
-    <p:push dir="l"/>
+  <p:transition>
+    <p:push/>
   </p:transition>
 </p:sld>
 </file>
@@ -4348,7 +4427,10 @@
       </a:bgFillStyleLst>
     </a:fmtScheme>
   </a:themeElements>
-  <a:objectDefaults/>
-  <a:extraClrSchemeLst/>
+  <a:extLst>
+    <a:ext uri="{05A4C25C-085E-4340-85A3-A5531E510DB2}">
+      <thm15:themeFamily xmlns:thm15="http://schemas.microsoft.com/office/thememl/2012/main" name="Office Theme" id="{62F939B6-93AF-4DB8-9C6B-D6C7DFDC589F}" vid="{4A3C46E8-61CC-4603-A589-7422A47A8E4A}"/>
+    </a:ext>
+  </a:extLst>
 </a:theme>
 </file>
</xml_diff>